<commit_message>
fix(02): move models.py to the chapter root and run demos with python -m
- models.py moved into 03_pydantic/ left 01_types/literal_demo.py,
  04_stages/app.py and pyrefly (which resolves from the chapter root)
  unable to import it; pages 26, 27 and 29 failed.
- Run scripts as `python -m <dir>.<module>` so the chapter root is on
  sys.path.
- Read order.json relative to __file__ in typo.py and app.py, and add
  04_stages/order.json.
- pyrefly 1.4.0 reveals json.loads as Any, not Unknown: update the
  README and slides 18, 32 and 38.

Co-Authored-By: Claude Opus 5.5 <noreply@anthropic.com>
</commit_message>
<xml_diff>
--- a/02_second_never_trust_raw_data/第2回_今日から始める静的型チェック.pptx
+++ b/02_second_never_trust_raw_data/第2回_今日から始める静的型チェック.pptx
@@ -1259,12 +1259,12 @@
           <a:lstStyle/>
           <a:p>
             <a:r>
-              <a:t>デモ⑤: reveal_type() を仕込んで Unknown と表示させる。チェッカが自分から『分かりません』と言うのが効く。</a:t>
-            </a:r>
-          </a:p>
-          <a:p>
-            <a:r>
-              <a:t>Unknown は「暗黙の Any」の表示名。Any という言葉を知っている人には、そう補足すればよい。</a:t>
+              <a:t>デモ⑤: reveal_type() を仕込んで Any と表示させる。チェッカが自分から『分かりません』と言うのが効く。</a:t>
+            </a:r>
+          </a:p>
+          <a:p>
+            <a:r>
+              <a:t>Any は「型が分からないので何でも通す」という印。0 errors と並んで出るところを見せる。</a:t>
             </a:r>
           </a:p>
           <a:p>
@@ -1959,7 +1959,7 @@
           </a:p>
           <a:p>
             <a:r>
-              <a:t>2章と4章が、ここで1本に繋がる。3章の Unknown が、モデルによって具体的な型に変わったから。</a:t>
+              <a:t>2章と4章が、ここで1本に繋がる。3章の Any が、モデルによって具体的な型に変わったから。</a:t>
             </a:r>
           </a:p>
           <a:p>
@@ -13773,7 +13773,7 @@
                 <a:ea typeface="Consolas"/>
                 <a:cs typeface="Consolas"/>
               </a:rPr>
-              <a:t> INFO revealed type: Unknown</a:t>
+              <a:t> INFO revealed type: Any</a:t>
             </a:r>
           </a:p>
           <a:p>
@@ -13908,7 +13908,7 @@
                 <a:ea typeface="Meiryo"/>
                 <a:cs typeface="Meiryo"/>
               </a:rPr>
-              <a:t>Unknown =「型が分からない」。型チェッカは、そこから先を検査しません。</a:t>
+              <a:t>Any =「型が分からない」。型チェッカは、そこから先を検査しません。</a:t>
             </a:r>
           </a:p>
         </p:txBody>
@@ -13949,7 +13949,7 @@
                 <a:ea typeface="Meiryo"/>
                 <a:cs typeface="Meiryo"/>
               </a:rPr>
-              <a:t>json.loads も、型情報のない外部ライブラリも、返ってくるのはこれです。境界を Unknown のまま通すと、内側でどれだけ型を書いても素通りになります。</a:t>
+              <a:t>json.loads も、型情報のない外部ライブラリも、返ってくるのはこれです。境界を Any のまま通すと、内側でどれだけ型を書いても素通りになります。</a:t>
             </a:r>
           </a:p>
         </p:txBody>
@@ -24706,7 +24706,7 @@
                 <a:ea typeface="Meiryo"/>
                 <a:cs typeface="Meiryo"/>
               </a:rPr>
-              <a:t>Unknown には勝てない</a:t>
+              <a:t>Any には勝てない</a:t>
             </a:r>
           </a:p>
         </p:txBody>
@@ -29406,7 +29406,7 @@
                 <a:ea typeface="Meiryo"/>
                 <a:cs typeface="Meiryo"/>
               </a:rPr>
-              <a:t>json は Unknown。'1500' が紛れ込んでも、例外すら出ずに流れていく</a:t>
+              <a:t>json は Any。'1500' が紛れ込んでも、例外すら出ずに流れていく</a:t>
             </a:r>
           </a:p>
         </p:txBody>

</xml_diff>